<commit_message>
Level 5 Lesson 4 draft listening audio (1:48)
</commit_message>
<xml_diff>
--- a/level5/slides/Level5_Lesson4_Slides.pptx
+++ b/level5/slides/Level5_Lesson4_Slides.pptx
@@ -8,32 +8,32 @@
     <p:notesMasterId r:id="rId22"/>
   </p:notesMasterIdLst>
   <p:sldIdLst>
-    <p:sldId id="939" r:id="rId33"/>
-    <p:sldId id="940" r:id="rId34"/>
-    <p:sldId id="941" r:id="rId35"/>
-    <p:sldId id="942" r:id="rId36"/>
-    <p:sldId id="943" r:id="rId31"/>
-    <p:sldId id="944" r:id="rId30"/>
-    <p:sldId id="945" r:id="rId29"/>
-    <p:sldId id="946" r:id="rId28"/>
-    <p:sldId id="947" r:id="rId27"/>
-    <p:sldId id="948" r:id="rId20"/>
-    <p:sldId id="949" r:id="rId18"/>
-    <p:sldId id="950" r:id="rId17"/>
-    <p:sldId id="951" r:id="rId16"/>
-    <p:sldId id="952" r:id="rId14"/>
-    <p:sldId id="953" r:id="rId13"/>
-    <p:sldId id="954" r:id="rId12"/>
-    <p:sldId id="955" r:id="rId11"/>
-    <p:sldId id="956" r:id="rId10"/>
-    <p:sldId id="957" r:id="rId8"/>
-    <p:sldId id="958" r:id="rId7"/>
-    <p:sldId id="959" r:id="rId6"/>
-    <p:sldId id="960" r:id="rId5"/>
-    <p:sldId id="961" r:id="rId4"/>
-    <p:sldId id="962" r:id="rId3"/>
-    <p:sldId id="963" r:id="rId57"/>
-    <p:sldId id="964" r:id="rId2"/>
+    <p:sldId id="991" r:id="rId33"/>
+    <p:sldId id="992" r:id="rId34"/>
+    <p:sldId id="993" r:id="rId35"/>
+    <p:sldId id="994" r:id="rId36"/>
+    <p:sldId id="995" r:id="rId31"/>
+    <p:sldId id="996" r:id="rId30"/>
+    <p:sldId id="997" r:id="rId29"/>
+    <p:sldId id="998" r:id="rId28"/>
+    <p:sldId id="999" r:id="rId27"/>
+    <p:sldId id="1000" r:id="rId20"/>
+    <p:sldId id="1001" r:id="rId18"/>
+    <p:sldId id="1002" r:id="rId17"/>
+    <p:sldId id="1003" r:id="rId16"/>
+    <p:sldId id="1004" r:id="rId14"/>
+    <p:sldId id="1005" r:id="rId13"/>
+    <p:sldId id="1006" r:id="rId12"/>
+    <p:sldId id="1007" r:id="rId11"/>
+    <p:sldId id="1008" r:id="rId10"/>
+    <p:sldId id="1009" r:id="rId8"/>
+    <p:sldId id="1010" r:id="rId7"/>
+    <p:sldId id="1011" r:id="rId6"/>
+    <p:sldId id="1012" r:id="rId5"/>
+    <p:sldId id="1013" r:id="rId4"/>
+    <p:sldId id="1014" r:id="rId3"/>
+    <p:sldId id="1015" r:id="rId57"/>
+    <p:sldId id="1016" r:id="rId2"/>
   </p:sldIdLst>
   <p:sldSz cx="12192000" cy="6858000"/>
   <p:notesSz cx="6858000" cy="12192000"/>
@@ -536,7 +536,7 @@
           </a:p>
           <a:p>
             <a:r>
-              <a:t>Audio: the listening audio for this lesson (about 2:15) is coming soon. It will use computer-generated voices (Chatterbox TTS cloned from synthetic Kokoro-82M reference clips); no recordings of real people. Until it is ready, read the listening script (in the notes of the Before You Listen slide) with a volunteer. The names and the story are invented.</a:t>
+              <a:t>Audio: synthetic voices, computer-generated (Chatterbox TTS cloned from Kokoro-82M reference clips). No recordings of real people. The names and the story are invented.</a:t>
             </a:r>
           </a:p>
           <a:p>
@@ -1417,116 +1417,6 @@
           <a:p>
             <a:r>
               <a:t>Picture: Twemoji graphics by Twitter, Inc. and other contributors (https://github.com/jdecked/twemoji), CC BY 4.0 (https://creativecommons.org/licenses/by/4.0/); resized and combined, with signs and labels (images/CREDITS.md).</a:t>
-            </a:r>
-          </a:p>
-          <a:p>
-            <a:r>
-              <a:t>Listening script (the audio is coming soon; until then, read it aloud with a volunteer at a normal, friendly speed):</a:t>
-            </a:r>
-          </a:p>
-          <a:p>
-            <a:r>
-              <a:t>Narrator: Lesson four. Andre is at the front desk. He wants to go to a meeting, but he did not call first.</a:t>
-            </a:r>
-          </a:p>
-          <a:p>
-            <a:r>
-              <a:t>Helen: Good afternoon. Do you have an appointment?</a:t>
-            </a:r>
-          </a:p>
-          <a:p>
-            <a:r>
-              <a:t>Andre: I want to go to the four o'clock meeting. I did not call this morning.</a:t>
-            </a:r>
-          </a:p>
-          <a:p>
-            <a:r>
-              <a:t>Helen: I'm sorry. You can't go in unless you call first. That rule is on the notice.</a:t>
-            </a:r>
-          </a:p>
-          <a:p>
-            <a:r>
-              <a:t>Andre: Even though I am on time?</a:t>
-            </a:r>
-          </a:p>
-          <a:p>
-            <a:r>
-              <a:t>Helen: Even though you are on time, you still need to confirm.</a:t>
-            </a:r>
-          </a:p>
-          <a:p>
-            <a:r>
-              <a:t>Andre: What do I have to do?</a:t>
-            </a:r>
-          </a:p>
-          <a:p>
-            <a:r>
-              <a:t>Helen: You have to sign the book, and you must wear a visitor badge.</a:t>
-            </a:r>
-          </a:p>
-          <a:p>
-            <a:r>
-              <a:t>Andre: Is there an exception if I already have permission?</a:t>
-            </a:r>
-          </a:p>
-          <a:p>
-            <a:r>
-              <a:t>Helen: Permission is not the same as an appointment. Unless you confirm, the desk cannot make an exception.</a:t>
-            </a:r>
-          </a:p>
-          <a:p>
-            <a:r>
-              <a:t>Helen: The requirement is on the door. Please read the policy before you sit down.</a:t>
-            </a:r>
-          </a:p>
-          <a:p>
-            <a:r>
-              <a:t>Mei: Hi, Andre. You can wait as long as the four o'clock group finishes on time.</a:t>
-            </a:r>
-          </a:p>
-          <a:p>
-            <a:r>
-              <a:t>Andre: What happens unless they finish?</a:t>
-            </a:r>
-          </a:p>
-          <a:p>
-            <a:r>
-              <a:t>Mei: Then the room is closed. If you call first next time, they will hold the room.</a:t>
-            </a:r>
-          </a:p>
-          <a:p>
-            <a:r>
-              <a:t>Helen: You can bring a guest as long as you tell the front desk.</a:t>
-            </a:r>
-          </a:p>
-          <a:p>
-            <a:r>
-              <a:t>Andre: I am going to call tomorrow. Can I cancel today's meeting?</a:t>
-            </a:r>
-          </a:p>
-          <a:p>
-            <a:r>
-              <a:t>Helen: Yes. I can cancel it, or you can wait. Office hours end at five.</a:t>
-            </a:r>
-          </a:p>
-          <a:p>
-            <a:r>
-              <a:t>Andre: What happens unless I call tomorrow too?</a:t>
-            </a:r>
-          </a:p>
-          <a:p>
-            <a:r>
-              <a:t>Mei: Call during office hours, from nine to five. Then they can confirm the room.</a:t>
-            </a:r>
-          </a:p>
-          <a:p>
-            <a:r>
-              <a:t>Andre: I'll wait. Thank you for explaining the policy.</a:t>
-            </a:r>
-          </a:p>
-          <a:p>
-            <a:r>
-              <a:t>Narrator: That's the end of the listening.</a:t>
             </a:r>
           </a:p>
         </p:txBody>
@@ -5361,9 +5251,9 @@
               <a:buNone/>
             </a:pPr>
             <a:r>
-              <a:rPr lang="en-US" sz="1800" dirty="0" b="0">
-                <a:solidFill>
-                  <a:srgbClr val="1B2236"/>
+              <a:rPr lang="en-US" sz="1800" dirty="0" b="1">
+                <a:solidFill>
+                  <a:srgbClr val="5B3FC4"/>
                 </a:solidFill>
                 <a:latin typeface="Lexend Deca" pitchFamily="34" charset="0"/>
                 <a:ea typeface="Lexend Deca" pitchFamily="34" charset="-122"/>
@@ -5371,7 +5261,7 @@
               </a:rPr>
               <a:t>sentence.</a:t>
             </a:r>
-            <a:endParaRPr lang="en-US" sz="1800" dirty="0" b="0"/>
+            <a:endParaRPr lang="en-US" sz="1800" dirty="0" b="1"/>
           </a:p>
         </p:txBody>
       </p:sp>
@@ -11185,7 +11075,7 @@
                 <a:ea typeface="Lexend Deca" pitchFamily="34" charset="-122"/>
                 <a:cs typeface="Lexend Deca" pitchFamily="34" charset="-120"/>
               </a:rPr>
-              <a:t>Audio (about 2:15): coming soon.</a:t>
+              <a:t>Audio: about 1:48. It plays once.</a:t>
             </a:r>
             <a:endParaRPr lang="en-US" sz="2200" dirty="0"/>
           </a:p>
@@ -25524,9 +25414,9 @@
               <a:buNone/>
             </a:pPr>
             <a:r>
-              <a:rPr lang="en-US" sz="1600" dirty="0" b="0">
-                <a:solidFill>
-                  <a:srgbClr val="5B3FC4"/>
+              <a:rPr lang="en-US" sz="1600" dirty="0" b="1">
+                <a:solidFill>
+                  <a:srgbClr val="1B2236"/>
                 </a:solidFill>
                 <a:latin typeface="Lexend Deca" pitchFamily="34" charset="0"/>
                 <a:ea typeface="Lexend Deca" pitchFamily="34" charset="-122"/>
@@ -25534,7 +25424,7 @@
               </a:rPr>
               <a:t>even though.</a:t>
             </a:r>
-            <a:endParaRPr lang="en-US" sz="1600" dirty="0" b="0"/>
+            <a:endParaRPr lang="en-US" sz="1600" dirty="0" b="1"/>
           </a:p>
         </p:txBody>
       </p:sp>
@@ -29728,7 +29618,7 @@
                 <a:ea typeface="Lexend Deca" pitchFamily="34" charset="-122"/>
                 <a:cs typeface="Lexend Deca" pitchFamily="34" charset="-120"/>
               </a:rPr>
-              <a:t>Audio (coming soon): synthetic voices made with Chatterbox TTS (MIT License), cloned from short synthetic reference clips made with Kokoro-82M (Apache License 2.0). No recordings of real people. Each file will carry an inaudible Perth watermark marking it as AI-generated. Font: Lexend Deca (OFL 1.1).</a:t>
+              <a:t>Audio: synthetic voices made with Chatterbox TTS (MIT License), cloned from short synthetic reference clips made with Kokoro-82M (Apache License 2.0). No recordings of real people were used. Each file carries an inaudible Perth watermark marking it as AI-generated. Font: Lexend Deca (OFL 1.1).</a:t>
             </a:r>
             <a:endParaRPr lang="en-US" sz="1350" dirty="0" b="0"/>
           </a:p>

</xml_diff>